<commit_message>
Clarify final metric threshold reporting
</commit_message>
<xml_diff>
--- a/final_report_package/AI1215_Final_Presentation.pptx
+++ b/final_report_package/AI1215_Final_Presentation.pptx
@@ -2398,6 +2398,10 @@
             <a:prstDash val="solid"/>
           </a:ln>
         </p:spPr>
+        <p:txBody xmlns:a="http://schemas.openxmlformats.org/drawingml/2006/main">
+          <a:bodyPr/>
+          <a:p/>
+        </p:txBody>
       </p:sp>
       <p:sp>
         <p:nvSpPr>
@@ -2531,6 +2535,10 @@
             <a:prstDash val="solid"/>
           </a:ln>
         </p:spPr>
+        <p:txBody xmlns:a="http://schemas.openxmlformats.org/drawingml/2006/main">
+          <a:bodyPr/>
+          <a:p/>
+        </p:txBody>
       </p:sp>
       <p:sp>
         <p:nvSpPr>
@@ -2664,6 +2672,10 @@
             <a:prstDash val="solid"/>
           </a:ln>
         </p:spPr>
+        <p:txBody xmlns:a="http://schemas.openxmlformats.org/drawingml/2006/main">
+          <a:bodyPr/>
+          <a:p/>
+        </p:txBody>
       </p:sp>
       <p:sp>
         <p:nvSpPr>
@@ -2710,7 +2722,7 @@
                   <a:srgbClr val="111111"/>
                 </a:solidFill>
               </a:rPr>
-              <a:t>42.3%</a:t>
+              <a:t>36.2%</a:t>
             </a:r>
           </a:p>
         </p:txBody>
@@ -2760,7 +2772,7 @@
                   <a:srgbClr val="555555"/>
                 </a:solidFill>
               </a:rPr>
-              <a:t>Recall at selected threshold</a:t>
+              <a:t>Recall at validation threshold</a:t>
             </a:r>
           </a:p>
         </p:txBody>
@@ -2797,6 +2809,10 @@
             <a:prstDash val="solid"/>
           </a:ln>
         </p:spPr>
+        <p:txBody xmlns:a="http://schemas.openxmlformats.org/drawingml/2006/main">
+          <a:bodyPr/>
+          <a:p/>
+        </p:txBody>
       </p:sp>
       <p:sp>
         <p:nvSpPr>
@@ -3260,6 +3276,10 @@
             <a:prstDash val="solid"/>
           </a:ln>
         </p:spPr>
+        <p:txBody xmlns:a="http://schemas.openxmlformats.org/drawingml/2006/main">
+          <a:bodyPr/>
+          <a:p/>
+        </p:txBody>
       </p:sp>
       <p:sp>
         <p:nvSpPr>
@@ -3393,6 +3413,10 @@
             <a:prstDash val="solid"/>
           </a:ln>
         </p:spPr>
+        <p:txBody xmlns:a="http://schemas.openxmlformats.org/drawingml/2006/main">
+          <a:bodyPr/>
+          <a:p/>
+        </p:txBody>
       </p:sp>
       <p:pic>
         <p:nvPicPr>
@@ -3448,6 +3472,10 @@
             <a:prstDash val="solid"/>
           </a:ln>
         </p:spPr>
+        <p:txBody xmlns:a="http://schemas.openxmlformats.org/drawingml/2006/main">
+          <a:bodyPr/>
+          <a:p/>
+        </p:txBody>
       </p:sp>
       <p:sp>
         <p:nvSpPr>
@@ -3481,6 +3509,10 @@
             <a:prstDash val="solid"/>
           </a:ln>
         </p:spPr>
+        <p:txBody xmlns:a="http://schemas.openxmlformats.org/drawingml/2006/main">
+          <a:bodyPr/>
+          <a:p/>
+        </p:txBody>
       </p:sp>
       <p:sp>
         <p:nvSpPr>
@@ -3564,6 +3596,10 @@
             <a:prstDash val="solid"/>
           </a:ln>
         </p:spPr>
+        <p:txBody xmlns:a="http://schemas.openxmlformats.org/drawingml/2006/main">
+          <a:bodyPr/>
+          <a:p/>
+        </p:txBody>
       </p:sp>
       <p:sp>
         <p:nvSpPr>
@@ -3647,6 +3683,10 @@
             <a:prstDash val="solid"/>
           </a:ln>
         </p:spPr>
+        <p:txBody xmlns:a="http://schemas.openxmlformats.org/drawingml/2006/main">
+          <a:bodyPr/>
+          <a:p/>
+        </p:txBody>
       </p:sp>
       <p:sp>
         <p:nvSpPr>
@@ -3730,6 +3770,10 @@
             <a:prstDash val="solid"/>
           </a:ln>
         </p:spPr>
+        <p:txBody xmlns:a="http://schemas.openxmlformats.org/drawingml/2006/main">
+          <a:bodyPr/>
+          <a:p/>
+        </p:txBody>
       </p:sp>
       <p:sp>
         <p:nvSpPr>
@@ -3813,6 +3857,10 @@
             <a:prstDash val="solid"/>
           </a:ln>
         </p:spPr>
+        <p:txBody xmlns:a="http://schemas.openxmlformats.org/drawingml/2006/main">
+          <a:bodyPr/>
+          <a:p/>
+        </p:txBody>
       </p:sp>
       <p:sp>
         <p:nvSpPr>
@@ -3896,6 +3944,10 @@
             <a:prstDash val="solid"/>
           </a:ln>
         </p:spPr>
+        <p:txBody xmlns:a="http://schemas.openxmlformats.org/drawingml/2006/main">
+          <a:bodyPr/>
+          <a:p/>
+        </p:txBody>
       </p:sp>
       <p:sp>
         <p:nvSpPr>
@@ -3979,6 +4031,10 @@
             <a:prstDash val="solid"/>
           </a:ln>
         </p:spPr>
+        <p:txBody xmlns:a="http://schemas.openxmlformats.org/drawingml/2006/main">
+          <a:bodyPr/>
+          <a:p/>
+        </p:txBody>
       </p:sp>
       <p:sp>
         <p:nvSpPr>
@@ -4062,6 +4118,10 @@
             <a:prstDash val="solid"/>
           </a:ln>
         </p:spPr>
+        <p:txBody xmlns:a="http://schemas.openxmlformats.org/drawingml/2006/main">
+          <a:bodyPr/>
+          <a:p/>
+        </p:txBody>
       </p:sp>
       <p:sp>
         <p:nvSpPr>
@@ -4145,6 +4205,10 @@
             <a:prstDash val="solid"/>
           </a:ln>
         </p:spPr>
+        <p:txBody xmlns:a="http://schemas.openxmlformats.org/drawingml/2006/main">
+          <a:bodyPr/>
+          <a:p/>
+        </p:txBody>
       </p:sp>
       <p:sp>
         <p:nvSpPr>
@@ -4228,6 +4292,10 @@
             <a:prstDash val="solid"/>
           </a:ln>
         </p:spPr>
+        <p:txBody xmlns:a="http://schemas.openxmlformats.org/drawingml/2006/main">
+          <a:bodyPr/>
+          <a:p/>
+        </p:txBody>
       </p:sp>
       <p:sp>
         <p:nvSpPr>
@@ -4311,6 +4379,10 @@
             <a:prstDash val="solid"/>
           </a:ln>
         </p:spPr>
+        <p:txBody xmlns:a="http://schemas.openxmlformats.org/drawingml/2006/main">
+          <a:bodyPr/>
+          <a:p/>
+        </p:txBody>
       </p:sp>
       <p:sp>
         <p:nvSpPr>
@@ -4394,6 +4466,10 @@
             <a:prstDash val="solid"/>
           </a:ln>
         </p:spPr>
+        <p:txBody xmlns:a="http://schemas.openxmlformats.org/drawingml/2006/main">
+          <a:bodyPr/>
+          <a:p/>
+        </p:txBody>
       </p:sp>
       <p:sp>
         <p:nvSpPr>
@@ -4477,6 +4553,10 @@
             <a:prstDash val="solid"/>
           </a:ln>
         </p:spPr>
+        <p:txBody xmlns:a="http://schemas.openxmlformats.org/drawingml/2006/main">
+          <a:bodyPr/>
+          <a:p/>
+        </p:txBody>
       </p:sp>
       <p:sp>
         <p:nvSpPr>
@@ -4560,6 +4640,10 @@
             <a:prstDash val="solid"/>
           </a:ln>
         </p:spPr>
+        <p:txBody xmlns:a="http://schemas.openxmlformats.org/drawingml/2006/main">
+          <a:bodyPr/>
+          <a:p/>
+        </p:txBody>
       </p:sp>
       <p:sp>
         <p:nvSpPr>
@@ -4643,6 +4727,10 @@
             <a:prstDash val="solid"/>
           </a:ln>
         </p:spPr>
+        <p:txBody xmlns:a="http://schemas.openxmlformats.org/drawingml/2006/main">
+          <a:bodyPr/>
+          <a:p/>
+        </p:txBody>
       </p:sp>
       <p:sp>
         <p:nvSpPr>
@@ -4726,6 +4814,10 @@
             <a:prstDash val="solid"/>
           </a:ln>
         </p:spPr>
+        <p:txBody xmlns:a="http://schemas.openxmlformats.org/drawingml/2006/main">
+          <a:bodyPr/>
+          <a:p/>
+        </p:txBody>
       </p:sp>
       <p:sp>
         <p:nvSpPr>
@@ -4938,6 +5030,10 @@
             <a:prstDash val="solid"/>
           </a:ln>
         </p:spPr>
+        <p:txBody xmlns:a="http://schemas.openxmlformats.org/drawingml/2006/main">
+          <a:bodyPr/>
+          <a:p/>
+        </p:txBody>
       </p:sp>
       <p:sp>
         <p:nvSpPr>
@@ -4971,6 +5067,10 @@
             <a:prstDash val="solid"/>
           </a:ln>
         </p:spPr>
+        <p:txBody xmlns:a="http://schemas.openxmlformats.org/drawingml/2006/main">
+          <a:bodyPr/>
+          <a:p/>
+        </p:txBody>
       </p:sp>
       <p:sp>
         <p:nvSpPr>
@@ -5104,6 +5204,10 @@
             <a:prstDash val="solid"/>
           </a:ln>
         </p:spPr>
+        <p:txBody xmlns:a="http://schemas.openxmlformats.org/drawingml/2006/main">
+          <a:bodyPr/>
+          <a:p/>
+        </p:txBody>
       </p:sp>
       <p:sp>
         <p:nvSpPr>
@@ -5237,6 +5341,10 @@
             <a:prstDash val="solid"/>
           </a:ln>
         </p:spPr>
+        <p:txBody xmlns:a="http://schemas.openxmlformats.org/drawingml/2006/main">
+          <a:bodyPr/>
+          <a:p/>
+        </p:txBody>
       </p:sp>
       <p:sp>
         <p:nvSpPr>
@@ -5283,7 +5391,7 @@
                   <a:srgbClr val="111111"/>
                 </a:solidFill>
               </a:rPr>
-              <a:t>42.3%</a:t>
+              <a:t>36.2%</a:t>
             </a:r>
           </a:p>
         </p:txBody>
@@ -5370,6 +5478,10 @@
             <a:prstDash val="solid"/>
           </a:ln>
         </p:spPr>
+        <p:txBody xmlns:a="http://schemas.openxmlformats.org/drawingml/2006/main">
+          <a:bodyPr/>
+          <a:p/>
+        </p:txBody>
       </p:sp>
       <p:sp>
         <p:nvSpPr>
@@ -5416,7 +5528,7 @@
                   <a:srgbClr val="111111"/>
                 </a:solidFill>
               </a:rPr>
-              <a:t>22.2%</a:t>
+              <a:t>24.2%</a:t>
             </a:r>
           </a:p>
         </p:txBody>
@@ -5503,6 +5615,10 @@
             <a:prstDash val="solid"/>
           </a:ln>
         </p:spPr>
+        <p:txBody xmlns:a="http://schemas.openxmlformats.org/drawingml/2006/main">
+          <a:bodyPr/>
+          <a:p/>
+        </p:txBody>
       </p:sp>
       <p:sp>
         <p:nvSpPr>
@@ -5536,6 +5652,10 @@
             <a:prstDash val="solid"/>
           </a:ln>
         </p:spPr>
+        <p:txBody xmlns:a="http://schemas.openxmlformats.org/drawingml/2006/main">
+          <a:bodyPr/>
+          <a:p/>
+        </p:txBody>
       </p:sp>
       <p:sp>
         <p:nvSpPr>
@@ -5619,6 +5739,10 @@
             <a:prstDash val="solid"/>
           </a:ln>
         </p:spPr>
+        <p:txBody xmlns:a="http://schemas.openxmlformats.org/drawingml/2006/main">
+          <a:bodyPr/>
+          <a:p/>
+        </p:txBody>
       </p:sp>
       <p:sp>
         <p:nvSpPr>
@@ -5702,6 +5826,10 @@
             <a:prstDash val="solid"/>
           </a:ln>
         </p:spPr>
+        <p:txBody xmlns:a="http://schemas.openxmlformats.org/drawingml/2006/main">
+          <a:bodyPr/>
+          <a:p/>
+        </p:txBody>
       </p:sp>
       <p:sp>
         <p:nvSpPr>
@@ -5785,6 +5913,10 @@
             <a:prstDash val="solid"/>
           </a:ln>
         </p:spPr>
+        <p:txBody xmlns:a="http://schemas.openxmlformats.org/drawingml/2006/main">
+          <a:bodyPr/>
+          <a:p/>
+        </p:txBody>
       </p:sp>
       <p:sp>
         <p:nvSpPr>
@@ -5831,7 +5963,7 @@
                   <a:srgbClr val="555555"/>
                 </a:solidFill>
               </a:rPr>
-              <a:t>0.2913</a:t>
+              <a:t>0.2898</a:t>
             </a:r>
           </a:p>
         </p:txBody>
@@ -5868,6 +6000,10 @@
             <a:prstDash val="solid"/>
           </a:ln>
         </p:spPr>
+        <p:txBody xmlns:a="http://schemas.openxmlformats.org/drawingml/2006/main">
+          <a:bodyPr/>
+          <a:p/>
+        </p:txBody>
       </p:sp>
       <p:sp>
         <p:nvSpPr>
@@ -5951,6 +6087,10 @@
             <a:prstDash val="solid"/>
           </a:ln>
         </p:spPr>
+        <p:txBody xmlns:a="http://schemas.openxmlformats.org/drawingml/2006/main">
+          <a:bodyPr/>
+          <a:p/>
+        </p:txBody>
       </p:sp>
       <p:sp>
         <p:nvSpPr>
@@ -5997,7 +6137,7 @@
                   <a:srgbClr val="555555"/>
                 </a:solidFill>
               </a:rPr>
-              <a:t>0.7733</a:t>
+              <a:t>0.8044</a:t>
             </a:r>
           </a:p>
         </p:txBody>
@@ -6034,6 +6174,10 @@
             <a:prstDash val="solid"/>
           </a:ln>
         </p:spPr>
+        <p:txBody xmlns:a="http://schemas.openxmlformats.org/drawingml/2006/main">
+          <a:bodyPr/>
+          <a:p/>
+        </p:txBody>
       </p:sp>
       <p:sp>
         <p:nvSpPr>
@@ -6117,6 +6261,10 @@
             <a:prstDash val="solid"/>
           </a:ln>
         </p:spPr>
+        <p:txBody xmlns:a="http://schemas.openxmlformats.org/drawingml/2006/main">
+          <a:bodyPr/>
+          <a:p/>
+        </p:txBody>
       </p:sp>
       <p:sp>
         <p:nvSpPr>
@@ -6163,7 +6311,7 @@
                   <a:srgbClr val="555555"/>
                 </a:solidFill>
               </a:rPr>
-              <a:t>691</a:t>
+              <a:t>592</a:t>
             </a:r>
           </a:p>
         </p:txBody>
@@ -6200,6 +6348,10 @@
             <a:prstDash val="solid"/>
           </a:ln>
         </p:spPr>
+        <p:txBody xmlns:a="http://schemas.openxmlformats.org/drawingml/2006/main">
+          <a:bodyPr/>
+          <a:p/>
+        </p:txBody>
       </p:sp>
       <p:sp>
         <p:nvSpPr>
@@ -6283,6 +6435,10 @@
             <a:prstDash val="solid"/>
           </a:ln>
         </p:spPr>
+        <p:txBody xmlns:a="http://schemas.openxmlformats.org/drawingml/2006/main">
+          <a:bodyPr/>
+          <a:p/>
+        </p:txBody>
       </p:sp>
       <p:sp>
         <p:nvSpPr>
@@ -6329,7 +6485,7 @@
                   <a:srgbClr val="555555"/>
                 </a:solidFill>
               </a:rPr>
-              <a:t>2,418</a:t>
+              <a:t>1,858</a:t>
             </a:r>
           </a:p>
         </p:txBody>
@@ -6366,6 +6522,10 @@
             <a:prstDash val="solid"/>
           </a:ln>
         </p:spPr>
+        <p:txBody xmlns:a="http://schemas.openxmlformats.org/drawingml/2006/main">
+          <a:bodyPr/>
+          <a:p/>
+        </p:txBody>
       </p:sp>
       <p:sp>
         <p:nvSpPr>
@@ -6449,6 +6609,10 @@
             <a:prstDash val="solid"/>
           </a:ln>
         </p:spPr>
+        <p:txBody xmlns:a="http://schemas.openxmlformats.org/drawingml/2006/main">
+          <a:bodyPr/>
+          <a:p/>
+        </p:txBody>
       </p:sp>
       <p:sp>
         <p:nvSpPr>
@@ -6495,7 +6659,7 @@
                   <a:srgbClr val="555555"/>
                 </a:solidFill>
               </a:rPr>
-              <a:t>944</a:t>
+              <a:t>1,043</a:t>
             </a:r>
           </a:p>
         </p:txBody>
@@ -6532,6 +6696,10 @@
             <a:prstDash val="solid"/>
           </a:ln>
         </p:spPr>
+        <p:txBody xmlns:a="http://schemas.openxmlformats.org/drawingml/2006/main">
+          <a:bodyPr/>
+          <a:p/>
+        </p:txBody>
       </p:sp>
       <p:sp>
         <p:nvSpPr>
@@ -6615,6 +6783,10 @@
             <a:prstDash val="solid"/>
           </a:ln>
         </p:spPr>
+        <p:txBody xmlns:a="http://schemas.openxmlformats.org/drawingml/2006/main">
+          <a:bodyPr/>
+          <a:p/>
+        </p:txBody>
       </p:sp>
       <p:sp>
         <p:nvSpPr>
@@ -6661,7 +6833,7 @@
                   <a:srgbClr val="555555"/>
                 </a:solidFill>
               </a:rPr>
-              <a:t>10,775</a:t>
+              <a:t>11,335</a:t>
             </a:r>
           </a:p>
         </p:txBody>
@@ -6728,7 +6900,7 @@
                   <a:srgbClr val="111111"/>
                 </a:solidFill>
               </a:rPr>
-              <a:t>• Final model catches 691 of 1,635 readmissions</a:t>
+              <a:t>• Final model catches 592 of 1,635 readmissions</a:t>
             </a:r>
           </a:p>
           <a:p xmlns:a="http://schemas.openxmlformats.org/drawingml/2006/main">
@@ -7011,6 +7183,10 @@
             <a:prstDash val="solid"/>
           </a:ln>
         </p:spPr>
+        <p:txBody xmlns:a="http://schemas.openxmlformats.org/drawingml/2006/main">
+          <a:bodyPr/>
+          <a:p/>
+        </p:txBody>
       </p:sp>
       <p:sp>
         <p:nvSpPr>
@@ -7144,6 +7320,10 @@
             <a:prstDash val="solid"/>
           </a:ln>
         </p:spPr>
+        <p:txBody xmlns:a="http://schemas.openxmlformats.org/drawingml/2006/main">
+          <a:bodyPr/>
+          <a:p/>
+        </p:txBody>
       </p:sp>
       <p:pic>
         <p:nvPicPr>
@@ -7199,6 +7379,10 @@
             <a:prstDash val="solid"/>
           </a:ln>
         </p:spPr>
+        <p:txBody xmlns:a="http://schemas.openxmlformats.org/drawingml/2006/main">
+          <a:bodyPr/>
+          <a:p/>
+        </p:txBody>
       </p:sp>
       <p:sp>
         <p:nvSpPr>
@@ -7232,6 +7416,10 @@
             <a:prstDash val="solid"/>
           </a:ln>
         </p:spPr>
+        <p:txBody xmlns:a="http://schemas.openxmlformats.org/drawingml/2006/main">
+          <a:bodyPr/>
+          <a:p/>
+        </p:txBody>
       </p:sp>
       <p:sp>
         <p:nvSpPr>
@@ -7315,6 +7503,10 @@
             <a:prstDash val="solid"/>
           </a:ln>
         </p:spPr>
+        <p:txBody xmlns:a="http://schemas.openxmlformats.org/drawingml/2006/main">
+          <a:bodyPr/>
+          <a:p/>
+        </p:txBody>
       </p:sp>
       <p:sp>
         <p:nvSpPr>
@@ -7398,6 +7590,10 @@
             <a:prstDash val="solid"/>
           </a:ln>
         </p:spPr>
+        <p:txBody xmlns:a="http://schemas.openxmlformats.org/drawingml/2006/main">
+          <a:bodyPr/>
+          <a:p/>
+        </p:txBody>
       </p:sp>
       <p:sp>
         <p:nvSpPr>
@@ -7481,6 +7677,10 @@
             <a:prstDash val="solid"/>
           </a:ln>
         </p:spPr>
+        <p:txBody xmlns:a="http://schemas.openxmlformats.org/drawingml/2006/main">
+          <a:bodyPr/>
+          <a:p/>
+        </p:txBody>
       </p:sp>
       <p:sp>
         <p:nvSpPr>
@@ -7564,6 +7764,10 @@
             <a:prstDash val="solid"/>
           </a:ln>
         </p:spPr>
+        <p:txBody xmlns:a="http://schemas.openxmlformats.org/drawingml/2006/main">
+          <a:bodyPr/>
+          <a:p/>
+        </p:txBody>
       </p:sp>
       <p:sp>
         <p:nvSpPr>
@@ -7647,6 +7851,10 @@
             <a:prstDash val="solid"/>
           </a:ln>
         </p:spPr>
+        <p:txBody xmlns:a="http://schemas.openxmlformats.org/drawingml/2006/main">
+          <a:bodyPr/>
+          <a:p/>
+        </p:txBody>
       </p:sp>
       <p:sp>
         <p:nvSpPr>
@@ -7730,6 +7938,10 @@
             <a:prstDash val="solid"/>
           </a:ln>
         </p:spPr>
+        <p:txBody xmlns:a="http://schemas.openxmlformats.org/drawingml/2006/main">
+          <a:bodyPr/>
+          <a:p/>
+        </p:txBody>
       </p:sp>
       <p:sp>
         <p:nvSpPr>
@@ -7813,6 +8025,10 @@
             <a:prstDash val="solid"/>
           </a:ln>
         </p:spPr>
+        <p:txBody xmlns:a="http://schemas.openxmlformats.org/drawingml/2006/main">
+          <a:bodyPr/>
+          <a:p/>
+        </p:txBody>
       </p:sp>
       <p:sp>
         <p:nvSpPr>
@@ -7896,6 +8112,10 @@
             <a:prstDash val="solid"/>
           </a:ln>
         </p:spPr>
+        <p:txBody xmlns:a="http://schemas.openxmlformats.org/drawingml/2006/main">
+          <a:bodyPr/>
+          <a:p/>
+        </p:txBody>
       </p:sp>
       <p:sp>
         <p:nvSpPr>
@@ -7979,6 +8199,10 @@
             <a:prstDash val="solid"/>
           </a:ln>
         </p:spPr>
+        <p:txBody xmlns:a="http://schemas.openxmlformats.org/drawingml/2006/main">
+          <a:bodyPr/>
+          <a:p/>
+        </p:txBody>
       </p:sp>
       <p:sp>
         <p:nvSpPr>
@@ -8062,6 +8286,10 @@
             <a:prstDash val="solid"/>
           </a:ln>
         </p:spPr>
+        <p:txBody xmlns:a="http://schemas.openxmlformats.org/drawingml/2006/main">
+          <a:bodyPr/>
+          <a:p/>
+        </p:txBody>
       </p:sp>
       <p:sp>
         <p:nvSpPr>
@@ -8145,6 +8373,10 @@
             <a:prstDash val="solid"/>
           </a:ln>
         </p:spPr>
+        <p:txBody xmlns:a="http://schemas.openxmlformats.org/drawingml/2006/main">
+          <a:bodyPr/>
+          <a:p/>
+        </p:txBody>
       </p:sp>
       <p:sp>
         <p:nvSpPr>
@@ -8228,6 +8460,10 @@
             <a:prstDash val="solid"/>
           </a:ln>
         </p:spPr>
+        <p:txBody xmlns:a="http://schemas.openxmlformats.org/drawingml/2006/main">
+          <a:bodyPr/>
+          <a:p/>
+        </p:txBody>
       </p:sp>
       <p:sp>
         <p:nvSpPr>
@@ -8311,6 +8547,10 @@
             <a:prstDash val="solid"/>
           </a:ln>
         </p:spPr>
+        <p:txBody xmlns:a="http://schemas.openxmlformats.org/drawingml/2006/main">
+          <a:bodyPr/>
+          <a:p/>
+        </p:txBody>
       </p:sp>
       <p:sp>
         <p:nvSpPr>
@@ -8394,6 +8634,10 @@
             <a:prstDash val="solid"/>
           </a:ln>
         </p:spPr>
+        <p:txBody xmlns:a="http://schemas.openxmlformats.org/drawingml/2006/main">
+          <a:bodyPr/>
+          <a:p/>
+        </p:txBody>
       </p:sp>
       <p:sp>
         <p:nvSpPr>
@@ -8656,6 +8900,10 @@
             <a:prstDash val="solid"/>
           </a:ln>
         </p:spPr>
+        <p:txBody xmlns:a="http://schemas.openxmlformats.org/drawingml/2006/main">
+          <a:bodyPr/>
+          <a:p/>
+        </p:txBody>
       </p:sp>
       <p:sp>
         <p:nvSpPr>
@@ -9270,6 +9518,10 @@
             <a:prstDash val="solid"/>
           </a:ln>
         </p:spPr>
+        <p:txBody xmlns:a="http://schemas.openxmlformats.org/drawingml/2006/main">
+          <a:bodyPr/>
+          <a:p/>
+        </p:txBody>
       </p:sp>
       <p:sp>
         <p:nvSpPr>
@@ -9303,6 +9555,10 @@
             <a:prstDash val="solid"/>
           </a:ln>
         </p:spPr>
+        <p:txBody xmlns:a="http://schemas.openxmlformats.org/drawingml/2006/main">
+          <a:bodyPr/>
+          <a:p/>
+        </p:txBody>
       </p:sp>
       <p:sp>
         <p:nvSpPr>
@@ -9436,6 +9692,10 @@
             <a:prstDash val="solid"/>
           </a:ln>
         </p:spPr>
+        <p:txBody xmlns:a="http://schemas.openxmlformats.org/drawingml/2006/main">
+          <a:bodyPr/>
+          <a:p/>
+        </p:txBody>
       </p:sp>
       <p:sp>
         <p:nvSpPr>
@@ -9569,6 +9829,10 @@
             <a:prstDash val="solid"/>
           </a:ln>
         </p:spPr>
+        <p:txBody xmlns:a="http://schemas.openxmlformats.org/drawingml/2006/main">
+          <a:bodyPr/>
+          <a:p/>
+        </p:txBody>
       </p:sp>
       <p:sp>
         <p:nvSpPr>
@@ -9702,6 +9966,10 @@
             <a:prstDash val="solid"/>
           </a:ln>
         </p:spPr>
+        <p:txBody xmlns:a="http://schemas.openxmlformats.org/drawingml/2006/main">
+          <a:bodyPr/>
+          <a:p/>
+        </p:txBody>
       </p:sp>
       <p:sp>
         <p:nvSpPr>
@@ -10114,6 +10382,10 @@
             <a:prstDash val="solid"/>
           </a:ln>
         </p:spPr>
+        <p:txBody xmlns:a="http://schemas.openxmlformats.org/drawingml/2006/main">
+          <a:bodyPr/>
+          <a:p/>
+        </p:txBody>
       </p:sp>
       <p:sp>
         <p:nvSpPr>
@@ -10147,6 +10419,10 @@
             <a:prstDash val="solid"/>
           </a:ln>
         </p:spPr>
+        <p:txBody xmlns:a="http://schemas.openxmlformats.org/drawingml/2006/main">
+          <a:bodyPr/>
+          <a:p/>
+        </p:txBody>
       </p:sp>
       <p:sp>
         <p:nvSpPr>
@@ -10230,6 +10506,10 @@
             <a:prstDash val="solid"/>
           </a:ln>
         </p:spPr>
+        <p:txBody xmlns:a="http://schemas.openxmlformats.org/drawingml/2006/main">
+          <a:bodyPr/>
+          <a:p/>
+        </p:txBody>
       </p:sp>
       <p:sp>
         <p:nvSpPr>
@@ -10643,6 +10923,10 @@
             <a:prstDash val="solid"/>
           </a:ln>
         </p:spPr>
+        <p:txBody xmlns:a="http://schemas.openxmlformats.org/drawingml/2006/main">
+          <a:bodyPr/>
+          <a:p/>
+        </p:txBody>
       </p:sp>
       <p:sp>
         <p:nvSpPr>
@@ -10676,6 +10960,10 @@
             <a:prstDash val="solid"/>
           </a:ln>
         </p:spPr>
+        <p:txBody xmlns:a="http://schemas.openxmlformats.org/drawingml/2006/main">
+          <a:bodyPr/>
+          <a:p/>
+        </p:txBody>
       </p:sp>
       <p:sp>
         <p:nvSpPr>
@@ -10809,6 +11097,10 @@
             <a:prstDash val="solid"/>
           </a:ln>
         </p:spPr>
+        <p:txBody xmlns:a="http://schemas.openxmlformats.org/drawingml/2006/main">
+          <a:bodyPr/>
+          <a:p/>
+        </p:txBody>
       </p:sp>
       <p:sp>
         <p:nvSpPr>
@@ -10942,6 +11234,10 @@
             <a:prstDash val="solid"/>
           </a:ln>
         </p:spPr>
+        <p:txBody xmlns:a="http://schemas.openxmlformats.org/drawingml/2006/main">
+          <a:bodyPr/>
+          <a:p/>
+        </p:txBody>
       </p:sp>
       <p:sp>
         <p:nvSpPr>
@@ -11455,6 +11751,10 @@
             <a:prstDash val="solid"/>
           </a:ln>
         </p:spPr>
+        <p:txBody xmlns:a="http://schemas.openxmlformats.org/drawingml/2006/main">
+          <a:bodyPr/>
+          <a:p/>
+        </p:txBody>
       </p:sp>
       <p:sp>
         <p:nvSpPr>
@@ -11488,6 +11788,10 @@
             <a:prstDash val="solid"/>
           </a:ln>
         </p:spPr>
+        <p:txBody xmlns:a="http://schemas.openxmlformats.org/drawingml/2006/main">
+          <a:bodyPr/>
+          <a:p/>
+        </p:txBody>
       </p:sp>
       <p:sp>
         <p:nvSpPr>
@@ -11671,6 +11975,10 @@
             <a:prstDash val="solid"/>
           </a:ln>
         </p:spPr>
+        <p:txBody xmlns:a="http://schemas.openxmlformats.org/drawingml/2006/main">
+          <a:bodyPr/>
+          <a:p/>
+        </p:txBody>
       </p:sp>
       <p:sp>
         <p:nvSpPr>
@@ -11854,6 +12162,10 @@
             <a:prstDash val="solid"/>
           </a:ln>
         </p:spPr>
+        <p:txBody xmlns:a="http://schemas.openxmlformats.org/drawingml/2006/main">
+          <a:bodyPr/>
+          <a:p/>
+        </p:txBody>
       </p:sp>
       <p:sp>
         <p:nvSpPr>
@@ -12037,6 +12349,10 @@
             <a:prstDash val="solid"/>
           </a:ln>
         </p:spPr>
+        <p:txBody xmlns:a="http://schemas.openxmlformats.org/drawingml/2006/main">
+          <a:bodyPr/>
+          <a:p/>
+        </p:txBody>
       </p:sp>
       <p:sp>
         <p:nvSpPr>
@@ -12220,6 +12536,10 @@
             <a:prstDash val="solid"/>
           </a:ln>
         </p:spPr>
+        <p:txBody xmlns:a="http://schemas.openxmlformats.org/drawingml/2006/main">
+          <a:bodyPr/>
+          <a:p/>
+        </p:txBody>
       </p:sp>
       <p:sp>
         <p:nvSpPr>
@@ -12632,6 +12952,10 @@
             <a:prstDash val="solid"/>
           </a:ln>
         </p:spPr>
+        <p:txBody xmlns:a="http://schemas.openxmlformats.org/drawingml/2006/main">
+          <a:bodyPr/>
+          <a:p/>
+        </p:txBody>
       </p:sp>
       <p:sp>
         <p:nvSpPr>
@@ -12765,6 +13089,10 @@
             <a:prstDash val="solid"/>
           </a:ln>
         </p:spPr>
+        <p:txBody xmlns:a="http://schemas.openxmlformats.org/drawingml/2006/main">
+          <a:bodyPr/>
+          <a:p/>
+        </p:txBody>
       </p:sp>
       <p:sp>
         <p:nvSpPr>
@@ -12882,6 +13210,10 @@
             <a:prstDash val="solid"/>
           </a:ln>
         </p:spPr>
+        <p:txBody xmlns:a="http://schemas.openxmlformats.org/drawingml/2006/main">
+          <a:bodyPr/>
+          <a:p/>
+        </p:txBody>
       </p:sp>
       <p:sp>
         <p:nvSpPr>
@@ -13015,6 +13347,10 @@
             <a:prstDash val="solid"/>
           </a:ln>
         </p:spPr>
+        <p:txBody xmlns:a="http://schemas.openxmlformats.org/drawingml/2006/main">
+          <a:bodyPr/>
+          <a:p/>
+        </p:txBody>
       </p:sp>
       <p:sp>
         <p:nvSpPr>
@@ -13377,6 +13713,10 @@
             <a:prstDash val="solid"/>
           </a:ln>
         </p:spPr>
+        <p:txBody xmlns:a="http://schemas.openxmlformats.org/drawingml/2006/main">
+          <a:bodyPr/>
+          <a:p/>
+        </p:txBody>
       </p:sp>
       <p:sp>
         <p:nvSpPr>
@@ -13410,6 +13750,10 @@
             <a:prstDash val="solid"/>
           </a:ln>
         </p:spPr>
+        <p:txBody xmlns:a="http://schemas.openxmlformats.org/drawingml/2006/main">
+          <a:bodyPr/>
+          <a:p/>
+        </p:txBody>
       </p:sp>
       <p:sp>
         <p:nvSpPr>
@@ -13443,6 +13787,10 @@
             <a:prstDash val="solid"/>
           </a:ln>
         </p:spPr>
+        <p:txBody xmlns:a="http://schemas.openxmlformats.org/drawingml/2006/main">
+          <a:bodyPr/>
+          <a:p/>
+        </p:txBody>
       </p:sp>
       <p:sp>
         <p:nvSpPr>
@@ -13526,6 +13874,10 @@
             <a:prstDash val="solid"/>
           </a:ln>
         </p:spPr>
+        <p:txBody xmlns:a="http://schemas.openxmlformats.org/drawingml/2006/main">
+          <a:bodyPr/>
+          <a:p/>
+        </p:txBody>
       </p:sp>
       <p:sp>
         <p:nvSpPr>
@@ -13609,6 +13961,10 @@
             <a:prstDash val="solid"/>
           </a:ln>
         </p:spPr>
+        <p:txBody xmlns:a="http://schemas.openxmlformats.org/drawingml/2006/main">
+          <a:bodyPr/>
+          <a:p/>
+        </p:txBody>
       </p:sp>
       <p:sp>
         <p:nvSpPr>
@@ -13692,6 +14048,10 @@
             <a:prstDash val="solid"/>
           </a:ln>
         </p:spPr>
+        <p:txBody xmlns:a="http://schemas.openxmlformats.org/drawingml/2006/main">
+          <a:bodyPr/>
+          <a:p/>
+        </p:txBody>
       </p:sp>
       <p:sp>
         <p:nvSpPr>
@@ -13775,6 +14135,10 @@
             <a:prstDash val="solid"/>
           </a:ln>
         </p:spPr>
+        <p:txBody xmlns:a="http://schemas.openxmlformats.org/drawingml/2006/main">
+          <a:bodyPr/>
+          <a:p/>
+        </p:txBody>
       </p:sp>
       <p:sp>
         <p:nvSpPr>
@@ -13858,6 +14222,10 @@
             <a:prstDash val="solid"/>
           </a:ln>
         </p:spPr>
+        <p:txBody xmlns:a="http://schemas.openxmlformats.org/drawingml/2006/main">
+          <a:bodyPr/>
+          <a:p/>
+        </p:txBody>
       </p:sp>
       <p:sp>
         <p:nvSpPr>
@@ -13941,6 +14309,10 @@
             <a:prstDash val="solid"/>
           </a:ln>
         </p:spPr>
+        <p:txBody xmlns:a="http://schemas.openxmlformats.org/drawingml/2006/main">
+          <a:bodyPr/>
+          <a:p/>
+        </p:txBody>
       </p:sp>
       <p:sp>
         <p:nvSpPr>
@@ -14024,6 +14396,10 @@
             <a:prstDash val="solid"/>
           </a:ln>
         </p:spPr>
+        <p:txBody xmlns:a="http://schemas.openxmlformats.org/drawingml/2006/main">
+          <a:bodyPr/>
+          <a:p/>
+        </p:txBody>
       </p:sp>
       <p:sp>
         <p:nvSpPr>
@@ -14107,6 +14483,10 @@
             <a:prstDash val="solid"/>
           </a:ln>
         </p:spPr>
+        <p:txBody xmlns:a="http://schemas.openxmlformats.org/drawingml/2006/main">
+          <a:bodyPr/>
+          <a:p/>
+        </p:txBody>
       </p:sp>
       <p:sp>
         <p:nvSpPr>
@@ -14190,6 +14570,10 @@
             <a:prstDash val="solid"/>
           </a:ln>
         </p:spPr>
+        <p:txBody xmlns:a="http://schemas.openxmlformats.org/drawingml/2006/main">
+          <a:bodyPr/>
+          <a:p/>
+        </p:txBody>
       </p:sp>
       <p:sp>
         <p:nvSpPr>
@@ -14273,6 +14657,10 @@
             <a:prstDash val="solid"/>
           </a:ln>
         </p:spPr>
+        <p:txBody xmlns:a="http://schemas.openxmlformats.org/drawingml/2006/main">
+          <a:bodyPr/>
+          <a:p/>
+        </p:txBody>
       </p:sp>
       <p:sp>
         <p:nvSpPr>
@@ -14356,6 +14744,10 @@
             <a:prstDash val="solid"/>
           </a:ln>
         </p:spPr>
+        <p:txBody xmlns:a="http://schemas.openxmlformats.org/drawingml/2006/main">
+          <a:bodyPr/>
+          <a:p/>
+        </p:txBody>
       </p:sp>
       <p:sp>
         <p:nvSpPr>
@@ -14439,6 +14831,10 @@
             <a:prstDash val="solid"/>
           </a:ln>
         </p:spPr>
+        <p:txBody xmlns:a="http://schemas.openxmlformats.org/drawingml/2006/main">
+          <a:bodyPr/>
+          <a:p/>
+        </p:txBody>
       </p:sp>
       <p:sp>
         <p:nvSpPr>
@@ -14522,6 +14918,10 @@
             <a:prstDash val="solid"/>
           </a:ln>
         </p:spPr>
+        <p:txBody xmlns:a="http://schemas.openxmlformats.org/drawingml/2006/main">
+          <a:bodyPr/>
+          <a:p/>
+        </p:txBody>
       </p:sp>
       <p:sp>
         <p:nvSpPr>
@@ -14605,6 +15005,10 @@
             <a:prstDash val="solid"/>
           </a:ln>
         </p:spPr>
+        <p:txBody xmlns:a="http://schemas.openxmlformats.org/drawingml/2006/main">
+          <a:bodyPr/>
+          <a:p/>
+        </p:txBody>
       </p:sp>
       <p:sp>
         <p:nvSpPr>
@@ -14688,6 +15092,10 @@
             <a:prstDash val="solid"/>
           </a:ln>
         </p:spPr>
+        <p:txBody xmlns:a="http://schemas.openxmlformats.org/drawingml/2006/main">
+          <a:bodyPr/>
+          <a:p/>
+        </p:txBody>
       </p:sp>
       <p:sp>
         <p:nvSpPr>
@@ -14771,6 +15179,10 @@
             <a:prstDash val="solid"/>
           </a:ln>
         </p:spPr>
+        <p:txBody xmlns:a="http://schemas.openxmlformats.org/drawingml/2006/main">
+          <a:bodyPr/>
+          <a:p/>
+        </p:txBody>
       </p:sp>
       <p:sp>
         <p:nvSpPr>
@@ -15251,6 +15663,10 @@
             <a:prstDash val="solid"/>
           </a:ln>
         </p:spPr>
+        <p:txBody xmlns:a="http://schemas.openxmlformats.org/drawingml/2006/main">
+          <a:bodyPr/>
+          <a:p/>
+        </p:txBody>
       </p:sp>
       <p:sp>
         <p:nvSpPr>
@@ -15384,6 +15800,10 @@
             <a:prstDash val="solid"/>
           </a:ln>
         </p:spPr>
+        <p:txBody xmlns:a="http://schemas.openxmlformats.org/drawingml/2006/main">
+          <a:bodyPr/>
+          <a:p/>
+        </p:txBody>
       </p:sp>
       <p:pic>
         <p:nvPicPr>
@@ -15439,6 +15859,10 @@
             <a:prstDash val="solid"/>
           </a:ln>
         </p:spPr>
+        <p:txBody xmlns:a="http://schemas.openxmlformats.org/drawingml/2006/main">
+          <a:bodyPr/>
+          <a:p/>
+        </p:txBody>
       </p:sp>
       <p:pic>
         <p:nvPicPr>
@@ -15673,6 +16097,10 @@
             <a:prstDash val="solid"/>
           </a:ln>
         </p:spPr>
+        <p:txBody xmlns:a="http://schemas.openxmlformats.org/drawingml/2006/main">
+          <a:bodyPr/>
+          <a:p/>
+        </p:txBody>
       </p:sp>
       <p:sp>
         <p:nvSpPr>
@@ -15706,6 +16134,10 @@
             <a:prstDash val="solid"/>
           </a:ln>
         </p:spPr>
+        <p:txBody xmlns:a="http://schemas.openxmlformats.org/drawingml/2006/main">
+          <a:bodyPr/>
+          <a:p/>
+        </p:txBody>
       </p:sp>
       <p:sp>
         <p:nvSpPr>
@@ -15839,6 +16271,10 @@
             <a:prstDash val="solid"/>
           </a:ln>
         </p:spPr>
+        <p:txBody xmlns:a="http://schemas.openxmlformats.org/drawingml/2006/main">
+          <a:bodyPr/>
+          <a:p/>
+        </p:txBody>
       </p:sp>
       <p:sp>
         <p:nvSpPr>
@@ -15972,6 +16408,10 @@
             <a:prstDash val="solid"/>
           </a:ln>
         </p:spPr>
+        <p:txBody xmlns:a="http://schemas.openxmlformats.org/drawingml/2006/main">
+          <a:bodyPr/>
+          <a:p/>
+        </p:txBody>
       </p:sp>
       <p:sp>
         <p:nvSpPr>
@@ -16105,6 +16545,10 @@
             <a:prstDash val="solid"/>
           </a:ln>
         </p:spPr>
+        <p:txBody xmlns:a="http://schemas.openxmlformats.org/drawingml/2006/main">
+          <a:bodyPr/>
+          <a:p/>
+        </p:txBody>
       </p:sp>
       <p:sp>
         <p:nvSpPr>
@@ -16238,6 +16682,10 @@
             <a:prstDash val="solid"/>
           </a:ln>
         </p:spPr>
+        <p:txBody xmlns:a="http://schemas.openxmlformats.org/drawingml/2006/main">
+          <a:bodyPr/>
+          <a:p/>
+        </p:txBody>
       </p:sp>
       <p:sp>
         <p:nvSpPr>
@@ -16371,6 +16819,10 @@
             <a:prstDash val="solid"/>
           </a:ln>
         </p:spPr>
+        <p:txBody xmlns:a="http://schemas.openxmlformats.org/drawingml/2006/main">
+          <a:bodyPr/>
+          <a:p/>
+        </p:txBody>
       </p:sp>
       <p:sp>
         <p:nvSpPr>
@@ -16783,6 +17235,10 @@
             <a:prstDash val="solid"/>
           </a:ln>
         </p:spPr>
+        <p:txBody xmlns:a="http://schemas.openxmlformats.org/drawingml/2006/main">
+          <a:bodyPr/>
+          <a:p/>
+        </p:txBody>
       </p:sp>
       <p:sp>
         <p:nvSpPr>
@@ -16816,6 +17272,10 @@
             <a:prstDash val="solid"/>
           </a:ln>
         </p:spPr>
+        <p:txBody xmlns:a="http://schemas.openxmlformats.org/drawingml/2006/main">
+          <a:bodyPr/>
+          <a:p/>
+        </p:txBody>
       </p:sp>
       <p:sp>
         <p:nvSpPr>
@@ -16849,6 +17309,10 @@
             <a:prstDash val="solid"/>
           </a:ln>
         </p:spPr>
+        <p:txBody xmlns:a="http://schemas.openxmlformats.org/drawingml/2006/main">
+          <a:bodyPr/>
+          <a:p/>
+        </p:txBody>
       </p:sp>
       <p:sp>
         <p:nvSpPr>
@@ -16932,6 +17396,10 @@
             <a:prstDash val="solid"/>
           </a:ln>
         </p:spPr>
+        <p:txBody xmlns:a="http://schemas.openxmlformats.org/drawingml/2006/main">
+          <a:bodyPr/>
+          <a:p/>
+        </p:txBody>
       </p:sp>
       <p:sp>
         <p:nvSpPr>
@@ -17015,6 +17483,10 @@
             <a:prstDash val="solid"/>
           </a:ln>
         </p:spPr>
+        <p:txBody xmlns:a="http://schemas.openxmlformats.org/drawingml/2006/main">
+          <a:bodyPr/>
+          <a:p/>
+        </p:txBody>
       </p:sp>
       <p:sp>
         <p:nvSpPr>
@@ -17098,6 +17570,10 @@
             <a:prstDash val="solid"/>
           </a:ln>
         </p:spPr>
+        <p:txBody xmlns:a="http://schemas.openxmlformats.org/drawingml/2006/main">
+          <a:bodyPr/>
+          <a:p/>
+        </p:txBody>
       </p:sp>
       <p:sp>
         <p:nvSpPr>
@@ -17181,6 +17657,10 @@
             <a:prstDash val="solid"/>
           </a:ln>
         </p:spPr>
+        <p:txBody xmlns:a="http://schemas.openxmlformats.org/drawingml/2006/main">
+          <a:bodyPr/>
+          <a:p/>
+        </p:txBody>
       </p:sp>
       <p:sp>
         <p:nvSpPr>
@@ -17264,6 +17744,10 @@
             <a:prstDash val="solid"/>
           </a:ln>
         </p:spPr>
+        <p:txBody xmlns:a="http://schemas.openxmlformats.org/drawingml/2006/main">
+          <a:bodyPr/>
+          <a:p/>
+        </p:txBody>
       </p:sp>
       <p:sp>
         <p:nvSpPr>
@@ -17347,6 +17831,10 @@
             <a:prstDash val="solid"/>
           </a:ln>
         </p:spPr>
+        <p:txBody xmlns:a="http://schemas.openxmlformats.org/drawingml/2006/main">
+          <a:bodyPr/>
+          <a:p/>
+        </p:txBody>
       </p:sp>
       <p:sp>
         <p:nvSpPr>
@@ -17430,6 +17918,10 @@
             <a:prstDash val="solid"/>
           </a:ln>
         </p:spPr>
+        <p:txBody xmlns:a="http://schemas.openxmlformats.org/drawingml/2006/main">
+          <a:bodyPr/>
+          <a:p/>
+        </p:txBody>
       </p:sp>
       <p:sp>
         <p:nvSpPr>
@@ -17513,6 +18005,10 @@
             <a:prstDash val="solid"/>
           </a:ln>
         </p:spPr>
+        <p:txBody xmlns:a="http://schemas.openxmlformats.org/drawingml/2006/main">
+          <a:bodyPr/>
+          <a:p/>
+        </p:txBody>
       </p:sp>
       <p:sp>
         <p:nvSpPr>
@@ -17596,6 +18092,10 @@
             <a:prstDash val="solid"/>
           </a:ln>
         </p:spPr>
+        <p:txBody xmlns:a="http://schemas.openxmlformats.org/drawingml/2006/main">
+          <a:bodyPr/>
+          <a:p/>
+        </p:txBody>
       </p:sp>
       <p:sp>
         <p:nvSpPr>
@@ -17679,6 +18179,10 @@
             <a:prstDash val="solid"/>
           </a:ln>
         </p:spPr>
+        <p:txBody xmlns:a="http://schemas.openxmlformats.org/drawingml/2006/main">
+          <a:bodyPr/>
+          <a:p/>
+        </p:txBody>
       </p:sp>
       <p:sp>
         <p:nvSpPr>
@@ -17762,6 +18266,10 @@
             <a:prstDash val="solid"/>
           </a:ln>
         </p:spPr>
+        <p:txBody xmlns:a="http://schemas.openxmlformats.org/drawingml/2006/main">
+          <a:bodyPr/>
+          <a:p/>
+        </p:txBody>
       </p:sp>
       <p:sp>
         <p:nvSpPr>
@@ -18074,6 +18582,10 @@
             <a:prstDash val="solid"/>
           </a:ln>
         </p:spPr>
+        <p:txBody xmlns:a="http://schemas.openxmlformats.org/drawingml/2006/main">
+          <a:bodyPr/>
+          <a:p/>
+        </p:txBody>
       </p:sp>
       <p:sp>
         <p:nvSpPr>
@@ -18107,6 +18619,10 @@
             <a:prstDash val="solid"/>
           </a:ln>
         </p:spPr>
+        <p:txBody xmlns:a="http://schemas.openxmlformats.org/drawingml/2006/main">
+          <a:bodyPr/>
+          <a:p/>
+        </p:txBody>
       </p:sp>
       <p:sp>
         <p:nvSpPr>
@@ -18240,6 +18756,10 @@
             <a:prstDash val="solid"/>
           </a:ln>
         </p:spPr>
+        <p:txBody xmlns:a="http://schemas.openxmlformats.org/drawingml/2006/main">
+          <a:bodyPr/>
+          <a:p/>
+        </p:txBody>
       </p:sp>
       <p:sp>
         <p:nvSpPr>
@@ -18373,6 +18893,10 @@
             <a:prstDash val="solid"/>
           </a:ln>
         </p:spPr>
+        <p:txBody xmlns:a="http://schemas.openxmlformats.org/drawingml/2006/main">
+          <a:bodyPr/>
+          <a:p/>
+        </p:txBody>
       </p:sp>
       <p:sp>
         <p:nvSpPr>
@@ -18886,6 +19410,10 @@
             <a:prstDash val="solid"/>
           </a:ln>
         </p:spPr>
+        <p:txBody xmlns:a="http://schemas.openxmlformats.org/drawingml/2006/main">
+          <a:bodyPr/>
+          <a:p/>
+        </p:txBody>
       </p:sp>
       <p:sp>
         <p:nvSpPr>
@@ -18919,6 +19447,10 @@
             <a:prstDash val="solid"/>
           </a:ln>
         </p:spPr>
+        <p:txBody xmlns:a="http://schemas.openxmlformats.org/drawingml/2006/main">
+          <a:bodyPr/>
+          <a:p/>
+        </p:txBody>
       </p:sp>
       <p:sp>
         <p:nvSpPr>
@@ -19086,6 +19618,10 @@
             <a:prstDash val="solid"/>
           </a:ln>
         </p:spPr>
+        <p:txBody xmlns:a="http://schemas.openxmlformats.org/drawingml/2006/main">
+          <a:bodyPr/>
+          <a:p/>
+        </p:txBody>
       </p:sp>
       <p:sp>
         <p:nvSpPr>
@@ -19270,6 +19806,10 @@
             <a:prstDash val="solid"/>
           </a:ln>
         </p:spPr>
+        <p:txBody xmlns:a="http://schemas.openxmlformats.org/drawingml/2006/main">
+          <a:bodyPr/>
+          <a:p/>
+        </p:txBody>
       </p:sp>
       <p:sp>
         <p:nvSpPr>
@@ -19454,6 +19994,10 @@
             <a:prstDash val="solid"/>
           </a:ln>
         </p:spPr>
+        <p:txBody xmlns:a="http://schemas.openxmlformats.org/drawingml/2006/main">
+          <a:bodyPr/>
+          <a:p/>
+        </p:txBody>
       </p:sp>
       <p:sp>
         <p:nvSpPr>

</xml_diff>